<commit_message>
feat: complete plan-phase 1
</commit_message>
<xml_diff>
--- a/页面布局.pptx
+++ b/页面布局.pptx
@@ -5,7 +5,8 @@
     <p:sldMasterId id="2147483648" r:id="rId1"/>
   </p:sldMasterIdLst>
   <p:sldIdLst>
-    <p:sldId id="256" r:id="rId2"/>
+    <p:sldId id="257" r:id="rId2"/>
+    <p:sldId id="256" r:id="rId3"/>
   </p:sldIdLst>
   <p:sldSz cx="12192000" cy="6858000"/>
   <p:notesSz cx="6858000" cy="9144000"/>
@@ -3326,7 +3327,7 @@
           <p:cNvPr id="4" name="矩形 3">
             <a:extLst>
               <a:ext uri="{FF2B5EF4-FFF2-40B4-BE49-F238E27FC236}">
-                <a16:creationId xmlns:a16="http://schemas.microsoft.com/office/drawing/2014/main" id="{C65F594A-B440-FCDA-AA3B-5A7BAE929EF3}"/>
+                <a16:creationId xmlns:a16="http://schemas.microsoft.com/office/drawing/2014/main" id="{EC619B95-5CBF-5468-6772-9DBDEC867712}"/>
               </a:ext>
             </a:extLst>
           </p:cNvPr>
@@ -3335,8 +3336,8 @@
         </p:nvSpPr>
         <p:spPr>
           <a:xfrm>
-            <a:off x="2402840" y="1788160"/>
-            <a:ext cx="6680200" cy="3581400"/>
+            <a:off x="847578" y="686190"/>
+            <a:ext cx="10958340" cy="5870917"/>
           </a:xfrm>
           <a:prstGeom prst="rect">
             <a:avLst/>
@@ -3365,12 +3366,67 @@
           </a:p>
         </p:txBody>
       </p:sp>
+      <p:sp>
+        <p:nvSpPr>
+          <p:cNvPr id="5" name="矩形 4">
+            <a:extLst>
+              <a:ext uri="{FF2B5EF4-FFF2-40B4-BE49-F238E27FC236}">
+                <a16:creationId xmlns:a16="http://schemas.microsoft.com/office/drawing/2014/main" id="{442F0E76-83CE-425C-BC87-C4E091480C47}"/>
+              </a:ext>
+            </a:extLst>
+          </p:cNvPr>
+          <p:cNvSpPr/>
+          <p:nvPr/>
+        </p:nvSpPr>
+        <p:spPr>
+          <a:xfrm>
+            <a:off x="1091030" y="917900"/>
+            <a:ext cx="2286390" cy="611163"/>
+          </a:xfrm>
+          <a:prstGeom prst="rect">
+            <a:avLst/>
+          </a:prstGeom>
+          <a:solidFill>
+            <a:schemeClr val="bg1">
+              <a:lumMod val="95000"/>
+            </a:schemeClr>
+          </a:solidFill>
+          <a:ln>
+            <a:noFill/>
+          </a:ln>
+        </p:spPr>
+        <p:style>
+          <a:lnRef idx="2">
+            <a:schemeClr val="dk1"/>
+          </a:lnRef>
+          <a:fillRef idx="1">
+            <a:schemeClr val="lt1"/>
+          </a:fillRef>
+          <a:effectRef idx="0">
+            <a:schemeClr val="dk1"/>
+          </a:effectRef>
+          <a:fontRef idx="minor">
+            <a:schemeClr val="dk1"/>
+          </a:fontRef>
+        </p:style>
+        <p:txBody>
+          <a:bodyPr rtlCol="0" anchor="ctr"/>
+          <a:lstStyle/>
+          <a:p>
+            <a:pPr algn="ctr"/>
+            <a:r>
+              <a:rPr lang="zh-CN" altLang="en-US" dirty="0"/>
+              <a:t>（图标）主页</a:t>
+            </a:r>
+          </a:p>
+        </p:txBody>
+      </p:sp>
       <p:cxnSp>
         <p:nvCxnSpPr>
           <p:cNvPr id="6" name="直接连接符 5">
             <a:extLst>
               <a:ext uri="{FF2B5EF4-FFF2-40B4-BE49-F238E27FC236}">
-                <a16:creationId xmlns:a16="http://schemas.microsoft.com/office/drawing/2014/main" id="{F0CC6497-AA8E-BD58-8AFC-B7891EEEC3F5}"/>
+                <a16:creationId xmlns:a16="http://schemas.microsoft.com/office/drawing/2014/main" id="{982964F5-B05E-5AA4-46B5-B21B22BFA856}"/>
               </a:ext>
             </a:extLst>
           </p:cNvPr>
@@ -3381,8 +3437,8 @@
         </p:nvCxnSpPr>
         <p:spPr>
           <a:xfrm>
-            <a:off x="2448560" y="2438400"/>
-            <a:ext cx="6680200" cy="0"/>
+            <a:off x="3453619" y="686189"/>
+            <a:ext cx="0" cy="5870917"/>
           </a:xfrm>
           <a:prstGeom prst="line">
             <a:avLst/>
@@ -3408,17 +3464,19 @@
           <p:cNvPr id="9" name="直接连接符 8">
             <a:extLst>
               <a:ext uri="{FF2B5EF4-FFF2-40B4-BE49-F238E27FC236}">
-                <a16:creationId xmlns:a16="http://schemas.microsoft.com/office/drawing/2014/main" id="{6A3B0995-3EDB-CFD0-26AC-C5C6BAAA27D1}"/>
-              </a:ext>
-            </a:extLst>
-          </p:cNvPr>
-          <p:cNvCxnSpPr/>
+                <a16:creationId xmlns:a16="http://schemas.microsoft.com/office/drawing/2014/main" id="{D803A0F7-5F0D-CCBA-5CAC-CD4C034EA865}"/>
+              </a:ext>
+            </a:extLst>
+          </p:cNvPr>
+          <p:cNvCxnSpPr>
+            <a:cxnSpLocks/>
+          </p:cNvCxnSpPr>
           <p:nvPr/>
         </p:nvCxnSpPr>
         <p:spPr>
-          <a:xfrm>
-            <a:off x="3271520" y="1793240"/>
-            <a:ext cx="0" cy="645160"/>
+          <a:xfrm flipV="1">
+            <a:off x="3453619" y="1494104"/>
+            <a:ext cx="8352299" cy="14265"/>
           </a:xfrm>
           <a:prstGeom prst="line">
             <a:avLst/>
@@ -3439,26 +3497,29 @@
           </a:fontRef>
         </p:style>
       </p:cxnSp>
-      <p:cxnSp>
-        <p:nvCxnSpPr>
-          <p:cNvPr id="11" name="直接连接符 10">
-            <a:extLst>
-              <a:ext uri="{FF2B5EF4-FFF2-40B4-BE49-F238E27FC236}">
-                <a16:creationId xmlns:a16="http://schemas.microsoft.com/office/drawing/2014/main" id="{CD6853C0-46CF-71A7-AE31-726DB3A34A08}"/>
-              </a:ext>
-            </a:extLst>
-          </p:cNvPr>
-          <p:cNvCxnSpPr/>
+      <p:sp>
+        <p:nvSpPr>
+          <p:cNvPr id="11" name="矩形 10">
+            <a:extLst>
+              <a:ext uri="{FF2B5EF4-FFF2-40B4-BE49-F238E27FC236}">
+                <a16:creationId xmlns:a16="http://schemas.microsoft.com/office/drawing/2014/main" id="{03DBC085-AE57-F4C8-0DAA-E5E52E276FA0}"/>
+              </a:ext>
+            </a:extLst>
+          </p:cNvPr>
+          <p:cNvSpPr/>
           <p:nvPr/>
-        </p:nvCxnSpPr>
+        </p:nvSpPr>
         <p:spPr>
           <a:xfrm>
-            <a:off x="4094480" y="1788160"/>
-            <a:ext cx="0" cy="650240"/>
+            <a:off x="3568114" y="778608"/>
+            <a:ext cx="1250852" cy="611163"/>
           </a:xfrm>
-          <a:prstGeom prst="line">
+          <a:prstGeom prst="rect">
             <a:avLst/>
           </a:prstGeom>
+          <a:ln>
+            <a:noFill/>
+          </a:ln>
         </p:spPr>
         <p:style>
           <a:lnRef idx="2">
@@ -3474,27 +3535,294 @@
             <a:schemeClr val="dk1"/>
           </a:fontRef>
         </p:style>
-      </p:cxnSp>
-      <p:cxnSp>
-        <p:nvCxnSpPr>
-          <p:cNvPr id="13" name="直接连接符 12">
-            <a:extLst>
-              <a:ext uri="{FF2B5EF4-FFF2-40B4-BE49-F238E27FC236}">
-                <a16:creationId xmlns:a16="http://schemas.microsoft.com/office/drawing/2014/main" id="{CA832CDB-2679-35D0-9DD2-593E1D9B4299}"/>
-              </a:ext>
-            </a:extLst>
-          </p:cNvPr>
-          <p:cNvCxnSpPr/>
+        <p:txBody>
+          <a:bodyPr rtlCol="0" anchor="ctr"/>
+          <a:lstStyle/>
+          <a:p>
+            <a:pPr algn="ctr"/>
+            <a:r>
+              <a:rPr lang="zh-CN" altLang="en-US" sz="2000" dirty="0"/>
+              <a:t>我的课堂</a:t>
+            </a:r>
+          </a:p>
+        </p:txBody>
+      </p:sp>
+      <p:pic>
+        <p:nvPicPr>
+          <p:cNvPr id="13" name="图片 12">
+            <a:extLst>
+              <a:ext uri="{FF2B5EF4-FFF2-40B4-BE49-F238E27FC236}">
+                <a16:creationId xmlns:a16="http://schemas.microsoft.com/office/drawing/2014/main" id="{797D10ED-682D-8922-D948-0AE0217C5DFA}"/>
+              </a:ext>
+            </a:extLst>
+          </p:cNvPr>
+          <p:cNvPicPr>
+            <a:picLocks noChangeAspect="1"/>
+          </p:cNvPicPr>
           <p:nvPr/>
-        </p:nvCxnSpPr>
+        </p:nvPicPr>
+        <p:blipFill>
+          <a:blip r:embed="rId2">
+            <a:extLst>
+              <a:ext uri="{28A0092B-C50C-407E-A947-70E740481C1C}">
+                <a14:useLocalDpi xmlns:a14="http://schemas.microsoft.com/office/drawing/2010/main" val="0"/>
+              </a:ext>
+            </a:extLst>
+          </a:blip>
+          <a:stretch>
+            <a:fillRect/>
+          </a:stretch>
+        </p:blipFill>
         <p:spPr>
           <a:xfrm>
-            <a:off x="6659880" y="2438400"/>
-            <a:ext cx="0" cy="2931160"/>
+            <a:off x="3703311" y="1717035"/>
+            <a:ext cx="2362217" cy="1371610"/>
           </a:xfrm>
-          <a:prstGeom prst="line">
+          <a:prstGeom prst="rect">
             <a:avLst/>
           </a:prstGeom>
+        </p:spPr>
+      </p:pic>
+      <p:pic>
+        <p:nvPicPr>
+          <p:cNvPr id="15" name="图片 14">
+            <a:extLst>
+              <a:ext uri="{FF2B5EF4-FFF2-40B4-BE49-F238E27FC236}">
+                <a16:creationId xmlns:a16="http://schemas.microsoft.com/office/drawing/2014/main" id="{0723BA9A-598F-B779-2B61-0577386B45AF}"/>
+              </a:ext>
+            </a:extLst>
+          </p:cNvPr>
+          <p:cNvPicPr>
+            <a:picLocks noChangeAspect="1"/>
+          </p:cNvPicPr>
+          <p:nvPr/>
+        </p:nvPicPr>
+        <p:blipFill>
+          <a:blip r:embed="rId3">
+            <a:extLst>
+              <a:ext uri="{28A0092B-C50C-407E-A947-70E740481C1C}">
+                <a14:useLocalDpi xmlns:a14="http://schemas.microsoft.com/office/drawing/2010/main" val="0"/>
+              </a:ext>
+            </a:extLst>
+          </a:blip>
+          <a:stretch>
+            <a:fillRect/>
+          </a:stretch>
+        </p:blipFill>
+        <p:spPr>
+          <a:xfrm>
+            <a:off x="6648783" y="1774185"/>
+            <a:ext cx="2381267" cy="1314460"/>
+          </a:xfrm>
+          <a:prstGeom prst="rect">
+            <a:avLst/>
+          </a:prstGeom>
+        </p:spPr>
+      </p:pic>
+      <p:pic>
+        <p:nvPicPr>
+          <p:cNvPr id="17" name="图片 16">
+            <a:extLst>
+              <a:ext uri="{FF2B5EF4-FFF2-40B4-BE49-F238E27FC236}">
+                <a16:creationId xmlns:a16="http://schemas.microsoft.com/office/drawing/2014/main" id="{825ACC1D-F9BD-3A05-5F38-03CD939068EA}"/>
+              </a:ext>
+            </a:extLst>
+          </p:cNvPr>
+          <p:cNvPicPr>
+            <a:picLocks noChangeAspect="1"/>
+          </p:cNvPicPr>
+          <p:nvPr/>
+        </p:nvPicPr>
+        <p:blipFill>
+          <a:blip r:embed="rId4">
+            <a:extLst>
+              <a:ext uri="{28A0092B-C50C-407E-A947-70E740481C1C}">
+                <a14:useLocalDpi xmlns:a14="http://schemas.microsoft.com/office/drawing/2010/main" val="0"/>
+              </a:ext>
+            </a:extLst>
+          </a:blip>
+          <a:stretch>
+            <a:fillRect/>
+          </a:stretch>
+        </p:blipFill>
+        <p:spPr>
+          <a:xfrm>
+            <a:off x="9262373" y="1759898"/>
+            <a:ext cx="2400318" cy="1285884"/>
+          </a:xfrm>
+          <a:prstGeom prst="rect">
+            <a:avLst/>
+          </a:prstGeom>
+        </p:spPr>
+      </p:pic>
+      <p:pic>
+        <p:nvPicPr>
+          <p:cNvPr id="19" name="图片 18">
+            <a:extLst>
+              <a:ext uri="{FF2B5EF4-FFF2-40B4-BE49-F238E27FC236}">
+                <a16:creationId xmlns:a16="http://schemas.microsoft.com/office/drawing/2014/main" id="{DB65FE98-75A0-56CA-7CFD-A39CBEE8128C}"/>
+              </a:ext>
+            </a:extLst>
+          </p:cNvPr>
+          <p:cNvPicPr>
+            <a:picLocks noChangeAspect="1"/>
+          </p:cNvPicPr>
+          <p:nvPr/>
+        </p:nvPicPr>
+        <p:blipFill>
+          <a:blip r:embed="rId5">
+            <a:extLst>
+              <a:ext uri="{28A0092B-C50C-407E-A947-70E740481C1C}">
+                <a14:useLocalDpi xmlns:a14="http://schemas.microsoft.com/office/drawing/2010/main" val="0"/>
+              </a:ext>
+            </a:extLst>
+          </a:blip>
+          <a:stretch>
+            <a:fillRect/>
+          </a:stretch>
+        </p:blipFill>
+        <p:spPr>
+          <a:xfrm>
+            <a:off x="3614044" y="3429000"/>
+            <a:ext cx="2409843" cy="1257309"/>
+          </a:xfrm>
+          <a:prstGeom prst="rect">
+            <a:avLst/>
+          </a:prstGeom>
+        </p:spPr>
+      </p:pic>
+      <p:pic>
+        <p:nvPicPr>
+          <p:cNvPr id="23" name="图片 22">
+            <a:extLst>
+              <a:ext uri="{FF2B5EF4-FFF2-40B4-BE49-F238E27FC236}">
+                <a16:creationId xmlns:a16="http://schemas.microsoft.com/office/drawing/2014/main" id="{73FF30D8-9EC3-F572-4DC1-BC60FE10A307}"/>
+              </a:ext>
+            </a:extLst>
+          </p:cNvPr>
+          <p:cNvPicPr>
+            <a:picLocks noChangeAspect="1"/>
+          </p:cNvPicPr>
+          <p:nvPr/>
+        </p:nvPicPr>
+        <p:blipFill>
+          <a:blip r:embed="rId5">
+            <a:extLst>
+              <a:ext uri="{28A0092B-C50C-407E-A947-70E740481C1C}">
+                <a14:useLocalDpi xmlns:a14="http://schemas.microsoft.com/office/drawing/2010/main" val="0"/>
+              </a:ext>
+            </a:extLst>
+          </a:blip>
+          <a:stretch>
+            <a:fillRect/>
+          </a:stretch>
+        </p:blipFill>
+        <p:spPr>
+          <a:xfrm>
+            <a:off x="6653812" y="3426512"/>
+            <a:ext cx="2409843" cy="1257309"/>
+          </a:xfrm>
+          <a:prstGeom prst="rect">
+            <a:avLst/>
+          </a:prstGeom>
+        </p:spPr>
+      </p:pic>
+      <p:pic>
+        <p:nvPicPr>
+          <p:cNvPr id="24" name="图片 23">
+            <a:extLst>
+              <a:ext uri="{FF2B5EF4-FFF2-40B4-BE49-F238E27FC236}">
+                <a16:creationId xmlns:a16="http://schemas.microsoft.com/office/drawing/2014/main" id="{D08175C6-4062-829E-4181-7814C3D37891}"/>
+              </a:ext>
+            </a:extLst>
+          </p:cNvPr>
+          <p:cNvPicPr>
+            <a:picLocks noChangeAspect="1"/>
+          </p:cNvPicPr>
+          <p:nvPr/>
+        </p:nvPicPr>
+        <p:blipFill>
+          <a:blip r:embed="rId5">
+            <a:extLst>
+              <a:ext uri="{28A0092B-C50C-407E-A947-70E740481C1C}">
+                <a14:useLocalDpi xmlns:a14="http://schemas.microsoft.com/office/drawing/2010/main" val="0"/>
+              </a:ext>
+            </a:extLst>
+          </a:blip>
+          <a:stretch>
+            <a:fillRect/>
+          </a:stretch>
+        </p:blipFill>
+        <p:spPr>
+          <a:xfrm>
+            <a:off x="9319877" y="3426511"/>
+            <a:ext cx="2409843" cy="1257309"/>
+          </a:xfrm>
+          <a:prstGeom prst="rect">
+            <a:avLst/>
+          </a:prstGeom>
+        </p:spPr>
+      </p:pic>
+      <p:pic>
+        <p:nvPicPr>
+          <p:cNvPr id="25" name="图片 24">
+            <a:extLst>
+              <a:ext uri="{FF2B5EF4-FFF2-40B4-BE49-F238E27FC236}">
+                <a16:creationId xmlns:a16="http://schemas.microsoft.com/office/drawing/2014/main" id="{D2ECBA75-7B36-DD7C-B82D-83967E02272A}"/>
+              </a:ext>
+            </a:extLst>
+          </p:cNvPr>
+          <p:cNvPicPr>
+            <a:picLocks noChangeAspect="1"/>
+          </p:cNvPicPr>
+          <p:nvPr/>
+        </p:nvPicPr>
+        <p:blipFill>
+          <a:blip r:embed="rId5">
+            <a:extLst>
+              <a:ext uri="{28A0092B-C50C-407E-A947-70E740481C1C}">
+                <a14:useLocalDpi xmlns:a14="http://schemas.microsoft.com/office/drawing/2010/main" val="0"/>
+              </a:ext>
+            </a:extLst>
+          </a:blip>
+          <a:stretch>
+            <a:fillRect/>
+          </a:stretch>
+        </p:blipFill>
+        <p:spPr>
+          <a:xfrm>
+            <a:off x="3614044" y="5020762"/>
+            <a:ext cx="2409843" cy="1257309"/>
+          </a:xfrm>
+          <a:prstGeom prst="rect">
+            <a:avLst/>
+          </a:prstGeom>
+        </p:spPr>
+      </p:pic>
+      <p:sp>
+        <p:nvSpPr>
+          <p:cNvPr id="26" name="矩形 25">
+            <a:extLst>
+              <a:ext uri="{FF2B5EF4-FFF2-40B4-BE49-F238E27FC236}">
+                <a16:creationId xmlns:a16="http://schemas.microsoft.com/office/drawing/2014/main" id="{2A6A3647-47AE-96D2-0468-06F15137F80E}"/>
+              </a:ext>
+            </a:extLst>
+          </p:cNvPr>
+          <p:cNvSpPr/>
+          <p:nvPr/>
+        </p:nvSpPr>
+        <p:spPr>
+          <a:xfrm>
+            <a:off x="1091030" y="1994860"/>
+            <a:ext cx="2286390" cy="611163"/>
+          </a:xfrm>
+          <a:prstGeom prst="rect">
+            <a:avLst/>
+          </a:prstGeom>
+          <a:noFill/>
+          <a:ln>
+            <a:noFill/>
+          </a:ln>
         </p:spPr>
         <p:style>
           <a:lnRef idx="2">
@@ -3510,479 +3838,731 @@
             <a:schemeClr val="dk1"/>
           </a:fontRef>
         </p:style>
-      </p:cxnSp>
-      <p:cxnSp>
-        <p:nvCxnSpPr>
-          <p:cNvPr id="15" name="直接连接符 14">
-            <a:extLst>
-              <a:ext uri="{FF2B5EF4-FFF2-40B4-BE49-F238E27FC236}">
-                <a16:creationId xmlns:a16="http://schemas.microsoft.com/office/drawing/2014/main" id="{D6E76A96-210E-7EDB-0BE4-03DC4A2338BB}"/>
-              </a:ext>
-            </a:extLst>
-          </p:cNvPr>
-          <p:cNvCxnSpPr/>
+        <p:txBody>
+          <a:bodyPr rtlCol="0" anchor="ctr"/>
+          <a:lstStyle/>
+          <a:p>
+            <a:pPr algn="ctr"/>
+            <a:r>
+              <a:rPr lang="zh-CN" altLang="en-US" dirty="0"/>
+              <a:t>（图标）设置</a:t>
+            </a:r>
+          </a:p>
+        </p:txBody>
+      </p:sp>
+    </p:spTree>
+    <p:extLst>
+      <p:ext uri="{BB962C8B-B14F-4D97-AF65-F5344CB8AC3E}">
+        <p14:creationId xmlns:p14="http://schemas.microsoft.com/office/powerpoint/2010/main" val="3072676372"/>
+      </p:ext>
+    </p:extLst>
+  </p:cSld>
+  <p:clrMapOvr>
+    <a:masterClrMapping/>
+  </p:clrMapOvr>
+</p:sld>
+</file>
+
+<file path=ppt/slides/slide2.xml><?xml version="1.0" encoding="utf-8"?>
+<p:sld xmlns:a="http://schemas.openxmlformats.org/drawingml/2006/main" xmlns:r="http://schemas.openxmlformats.org/officeDocument/2006/relationships" xmlns:p="http://schemas.openxmlformats.org/presentationml/2006/main">
+  <p:cSld>
+    <p:spTree>
+      <p:nvGrpSpPr>
+        <p:cNvPr id="1" name=""/>
+        <p:cNvGrpSpPr/>
+        <p:nvPr/>
+      </p:nvGrpSpPr>
+      <p:grpSpPr>
+        <a:xfrm>
+          <a:off x="0" y="0"/>
+          <a:ext cx="0" cy="0"/>
+          <a:chOff x="0" y="0"/>
+          <a:chExt cx="0" cy="0"/>
+        </a:xfrm>
+      </p:grpSpPr>
+      <p:grpSp>
+        <p:nvGrpSpPr>
+          <p:cNvPr id="30" name="组合 29">
+            <a:extLst>
+              <a:ext uri="{FF2B5EF4-FFF2-40B4-BE49-F238E27FC236}">
+                <a16:creationId xmlns:a16="http://schemas.microsoft.com/office/drawing/2014/main" id="{4DB6059C-1360-1537-C4D9-6020C1701D43}"/>
+              </a:ext>
+            </a:extLst>
+          </p:cNvPr>
+          <p:cNvGrpSpPr/>
           <p:nvPr/>
-        </p:nvCxnSpPr>
-        <p:spPr>
+        </p:nvGrpSpPr>
+        <p:grpSpPr>
           <a:xfrm>
-            <a:off x="6659880" y="3896360"/>
-            <a:ext cx="2423160" cy="0"/>
+            <a:off x="2402840" y="1212567"/>
+            <a:ext cx="6725920" cy="4156993"/>
+            <a:chOff x="2402840" y="1212567"/>
+            <a:chExt cx="6725920" cy="4156993"/>
           </a:xfrm>
-          <a:prstGeom prst="line">
-            <a:avLst/>
-          </a:prstGeom>
-        </p:spPr>
-        <p:style>
-          <a:lnRef idx="2">
-            <a:schemeClr val="dk1"/>
-          </a:lnRef>
-          <a:fillRef idx="1">
-            <a:schemeClr val="lt1"/>
-          </a:fillRef>
-          <a:effectRef idx="0">
-            <a:schemeClr val="dk1"/>
-          </a:effectRef>
-          <a:fontRef idx="minor">
-            <a:schemeClr val="dk1"/>
-          </a:fontRef>
-        </p:style>
-      </p:cxnSp>
-      <p:sp>
-        <p:nvSpPr>
-          <p:cNvPr id="18" name="文本框 17">
-            <a:extLst>
-              <a:ext uri="{FF2B5EF4-FFF2-40B4-BE49-F238E27FC236}">
-                <a16:creationId xmlns:a16="http://schemas.microsoft.com/office/drawing/2014/main" id="{1CA803F5-C03C-E869-29D6-F1866DE73D54}"/>
-              </a:ext>
-            </a:extLst>
-          </p:cNvPr>
-          <p:cNvSpPr txBox="1"/>
-          <p:nvPr/>
-        </p:nvSpPr>
-        <p:spPr>
-          <a:xfrm>
-            <a:off x="6820882" y="2961640"/>
-            <a:ext cx="2262158" cy="646331"/>
-          </a:xfrm>
-          <a:prstGeom prst="rect">
-            <a:avLst/>
-          </a:prstGeom>
-          <a:noFill/>
-        </p:spPr>
-        <p:txBody>
-          <a:bodyPr wrap="none" rtlCol="0">
-            <a:spAutoFit/>
-          </a:bodyPr>
-          <a:lstStyle/>
-          <a:p>
-            <a:pPr algn="ctr"/>
-            <a:r>
-              <a:rPr lang="zh-CN" altLang="en-US" dirty="0"/>
-              <a:t>讲台区</a:t>
-            </a:r>
-            <a:endParaRPr lang="en-US" altLang="zh-CN" dirty="0"/>
-          </a:p>
-          <a:p>
-            <a:pPr algn="ctr"/>
-            <a:r>
-              <a:rPr lang="zh-CN" altLang="en-US" dirty="0"/>
-              <a:t>当前上台的学生头像</a:t>
-            </a:r>
-          </a:p>
-        </p:txBody>
-      </p:sp>
-      <p:sp>
-        <p:nvSpPr>
-          <p:cNvPr id="19" name="文本框 18">
-            <a:extLst>
-              <a:ext uri="{FF2B5EF4-FFF2-40B4-BE49-F238E27FC236}">
-                <a16:creationId xmlns:a16="http://schemas.microsoft.com/office/drawing/2014/main" id="{E56D5EAE-D6B8-AFE5-BFB5-80C20A3266D1}"/>
-              </a:ext>
-            </a:extLst>
-          </p:cNvPr>
-          <p:cNvSpPr txBox="1"/>
-          <p:nvPr/>
-        </p:nvSpPr>
-        <p:spPr>
-          <a:xfrm>
-            <a:off x="7329884" y="4309795"/>
-            <a:ext cx="1107996" cy="646331"/>
-          </a:xfrm>
-          <a:prstGeom prst="rect">
-            <a:avLst/>
-          </a:prstGeom>
-          <a:noFill/>
-        </p:spPr>
-        <p:txBody>
-          <a:bodyPr wrap="none" rtlCol="0">
-            <a:spAutoFit/>
-          </a:bodyPr>
-          <a:lstStyle/>
-          <a:p>
-            <a:pPr algn="ctr"/>
-            <a:r>
-              <a:rPr lang="zh-CN" altLang="en-US" dirty="0"/>
-              <a:t>教师区</a:t>
-            </a:r>
-            <a:endParaRPr lang="en-US" altLang="zh-CN" dirty="0"/>
-          </a:p>
-          <a:p>
-            <a:pPr algn="ctr"/>
-            <a:r>
-              <a:rPr lang="zh-CN" altLang="en-US" dirty="0"/>
-              <a:t>教师头像</a:t>
-            </a:r>
-          </a:p>
-        </p:txBody>
-      </p:sp>
-      <p:sp>
-        <p:nvSpPr>
-          <p:cNvPr id="20" name="文本框 19">
-            <a:extLst>
-              <a:ext uri="{FF2B5EF4-FFF2-40B4-BE49-F238E27FC236}">
-                <a16:creationId xmlns:a16="http://schemas.microsoft.com/office/drawing/2014/main" id="{8AD0230A-5180-1EEC-137B-B7434374EE34}"/>
-              </a:ext>
-            </a:extLst>
-          </p:cNvPr>
-          <p:cNvSpPr txBox="1"/>
-          <p:nvPr/>
-        </p:nvSpPr>
-        <p:spPr>
-          <a:xfrm>
-            <a:off x="3939308" y="3711694"/>
-            <a:ext cx="877163" cy="646331"/>
-          </a:xfrm>
-          <a:prstGeom prst="rect">
-            <a:avLst/>
-          </a:prstGeom>
-          <a:noFill/>
-        </p:spPr>
-        <p:txBody>
-          <a:bodyPr wrap="none" rtlCol="0">
-            <a:spAutoFit/>
-          </a:bodyPr>
-          <a:lstStyle/>
-          <a:p>
-            <a:r>
-              <a:rPr lang="zh-CN" altLang="en-US" dirty="0"/>
-              <a:t>课件区</a:t>
-            </a:r>
-            <a:endParaRPr lang="en-US" altLang="zh-CN" dirty="0"/>
-          </a:p>
-          <a:p>
-            <a:pPr algn="ctr"/>
-            <a:r>
-              <a:rPr lang="zh-CN" altLang="en-US" dirty="0"/>
-              <a:t>图片</a:t>
-            </a:r>
-          </a:p>
-        </p:txBody>
-      </p:sp>
-      <p:cxnSp>
-        <p:nvCxnSpPr>
-          <p:cNvPr id="21" name="直接连接符 20">
-            <a:extLst>
-              <a:ext uri="{FF2B5EF4-FFF2-40B4-BE49-F238E27FC236}">
-                <a16:creationId xmlns:a16="http://schemas.microsoft.com/office/drawing/2014/main" id="{6F854512-E40A-E0B8-772E-2EF2C11D6E4B}"/>
-              </a:ext>
-            </a:extLst>
-          </p:cNvPr>
-          <p:cNvCxnSpPr/>
-          <p:nvPr/>
-        </p:nvCxnSpPr>
-        <p:spPr>
-          <a:xfrm>
-            <a:off x="4881880" y="1793240"/>
-            <a:ext cx="0" cy="645160"/>
-          </a:xfrm>
-          <a:prstGeom prst="line">
-            <a:avLst/>
-          </a:prstGeom>
-        </p:spPr>
-        <p:style>
-          <a:lnRef idx="2">
-            <a:schemeClr val="dk1"/>
-          </a:lnRef>
-          <a:fillRef idx="1">
-            <a:schemeClr val="lt1"/>
-          </a:fillRef>
-          <a:effectRef idx="0">
-            <a:schemeClr val="dk1"/>
-          </a:effectRef>
-          <a:fontRef idx="minor">
-            <a:schemeClr val="dk1"/>
-          </a:fontRef>
-        </p:style>
-      </p:cxnSp>
-      <p:cxnSp>
-        <p:nvCxnSpPr>
-          <p:cNvPr id="22" name="直接连接符 21">
-            <a:extLst>
-              <a:ext uri="{FF2B5EF4-FFF2-40B4-BE49-F238E27FC236}">
-                <a16:creationId xmlns:a16="http://schemas.microsoft.com/office/drawing/2014/main" id="{B78D0309-DCF7-1C9F-6B34-C1F31BAF5F92}"/>
-              </a:ext>
-            </a:extLst>
-          </p:cNvPr>
-          <p:cNvCxnSpPr/>
-          <p:nvPr/>
-        </p:nvCxnSpPr>
-        <p:spPr>
-          <a:xfrm>
-            <a:off x="5633720" y="1788160"/>
-            <a:ext cx="0" cy="645160"/>
-          </a:xfrm>
-          <a:prstGeom prst="line">
-            <a:avLst/>
-          </a:prstGeom>
-        </p:spPr>
-        <p:style>
-          <a:lnRef idx="2">
-            <a:schemeClr val="dk1"/>
-          </a:lnRef>
-          <a:fillRef idx="1">
-            <a:schemeClr val="lt1"/>
-          </a:fillRef>
-          <a:effectRef idx="0">
-            <a:schemeClr val="dk1"/>
-          </a:effectRef>
-          <a:fontRef idx="minor">
-            <a:schemeClr val="dk1"/>
-          </a:fontRef>
-        </p:style>
-      </p:cxnSp>
-      <p:cxnSp>
-        <p:nvCxnSpPr>
-          <p:cNvPr id="23" name="直接连接符 22">
-            <a:extLst>
-              <a:ext uri="{FF2B5EF4-FFF2-40B4-BE49-F238E27FC236}">
-                <a16:creationId xmlns:a16="http://schemas.microsoft.com/office/drawing/2014/main" id="{7996573E-2F88-136E-7BAA-AE744BAE7FE0}"/>
-              </a:ext>
-            </a:extLst>
-          </p:cNvPr>
-          <p:cNvCxnSpPr/>
-          <p:nvPr/>
-        </p:nvCxnSpPr>
-        <p:spPr>
-          <a:xfrm>
-            <a:off x="6421120" y="1795780"/>
-            <a:ext cx="0" cy="645160"/>
-          </a:xfrm>
-          <a:prstGeom prst="line">
-            <a:avLst/>
-          </a:prstGeom>
-        </p:spPr>
-        <p:style>
-          <a:lnRef idx="2">
-            <a:schemeClr val="dk1"/>
-          </a:lnRef>
-          <a:fillRef idx="1">
-            <a:schemeClr val="lt1"/>
-          </a:fillRef>
-          <a:effectRef idx="0">
-            <a:schemeClr val="dk1"/>
-          </a:effectRef>
-          <a:fontRef idx="minor">
-            <a:schemeClr val="dk1"/>
-          </a:fontRef>
-        </p:style>
-      </p:cxnSp>
-      <p:cxnSp>
-        <p:nvCxnSpPr>
-          <p:cNvPr id="24" name="直接连接符 23">
-            <a:extLst>
-              <a:ext uri="{FF2B5EF4-FFF2-40B4-BE49-F238E27FC236}">
-                <a16:creationId xmlns:a16="http://schemas.microsoft.com/office/drawing/2014/main" id="{B22994B3-61DE-C9E1-9F1D-0537084832B2}"/>
-              </a:ext>
-            </a:extLst>
-          </p:cNvPr>
-          <p:cNvCxnSpPr/>
-          <p:nvPr/>
-        </p:nvCxnSpPr>
-        <p:spPr>
-          <a:xfrm>
-            <a:off x="7374880" y="1788160"/>
-            <a:ext cx="0" cy="645160"/>
-          </a:xfrm>
-          <a:prstGeom prst="line">
-            <a:avLst/>
-          </a:prstGeom>
-        </p:spPr>
-        <p:style>
-          <a:lnRef idx="2">
-            <a:schemeClr val="dk1"/>
-          </a:lnRef>
-          <a:fillRef idx="1">
-            <a:schemeClr val="lt1"/>
-          </a:fillRef>
-          <a:effectRef idx="0">
-            <a:schemeClr val="dk1"/>
-          </a:effectRef>
-          <a:fontRef idx="minor">
-            <a:schemeClr val="dk1"/>
-          </a:fontRef>
-        </p:style>
-      </p:cxnSp>
-      <p:cxnSp>
-        <p:nvCxnSpPr>
-          <p:cNvPr id="25" name="直接连接符 24">
-            <a:extLst>
-              <a:ext uri="{FF2B5EF4-FFF2-40B4-BE49-F238E27FC236}">
-                <a16:creationId xmlns:a16="http://schemas.microsoft.com/office/drawing/2014/main" id="{65B06274-DF29-4A65-E54A-86B1CE4758AD}"/>
-              </a:ext>
-            </a:extLst>
-          </p:cNvPr>
-          <p:cNvCxnSpPr/>
-          <p:nvPr/>
-        </p:nvCxnSpPr>
-        <p:spPr>
-          <a:xfrm>
-            <a:off x="8177520" y="1828800"/>
-            <a:ext cx="0" cy="645160"/>
-          </a:xfrm>
-          <a:prstGeom prst="line">
-            <a:avLst/>
-          </a:prstGeom>
-        </p:spPr>
-        <p:style>
-          <a:lnRef idx="2">
-            <a:schemeClr val="dk1"/>
-          </a:lnRef>
-          <a:fillRef idx="1">
-            <a:schemeClr val="lt1"/>
-          </a:fillRef>
-          <a:effectRef idx="0">
-            <a:schemeClr val="dk1"/>
-          </a:effectRef>
-          <a:fontRef idx="minor">
-            <a:schemeClr val="dk1"/>
-          </a:fontRef>
-        </p:style>
-      </p:cxnSp>
-      <p:sp>
-        <p:nvSpPr>
-          <p:cNvPr id="26" name="文本框 25">
-            <a:extLst>
-              <a:ext uri="{FF2B5EF4-FFF2-40B4-BE49-F238E27FC236}">
-                <a16:creationId xmlns:a16="http://schemas.microsoft.com/office/drawing/2014/main" id="{BB3A0EDF-924E-5208-BCC3-D58961197EFC}"/>
-              </a:ext>
-            </a:extLst>
-          </p:cNvPr>
-          <p:cNvSpPr txBox="1"/>
-          <p:nvPr/>
-        </p:nvSpPr>
-        <p:spPr>
-          <a:xfrm>
-            <a:off x="2553583" y="1871990"/>
-            <a:ext cx="638316" cy="523220"/>
-          </a:xfrm>
-          <a:prstGeom prst="rect">
-            <a:avLst/>
-          </a:prstGeom>
-          <a:noFill/>
-        </p:spPr>
-        <p:txBody>
-          <a:bodyPr wrap="none" rtlCol="0">
-            <a:spAutoFit/>
-          </a:bodyPr>
-          <a:lstStyle/>
-          <a:p>
-            <a:r>
-              <a:rPr lang="zh-CN" altLang="en-US" sz="1400" dirty="0"/>
-              <a:t>学生</a:t>
-            </a:r>
-            <a:r>
-              <a:rPr lang="en-US" altLang="zh-CN" sz="1400" dirty="0"/>
-              <a:t>1</a:t>
-            </a:r>
-          </a:p>
-          <a:p>
-            <a:r>
-              <a:rPr lang="zh-CN" altLang="en-US" sz="1400" dirty="0"/>
-              <a:t>头像</a:t>
-            </a:r>
-          </a:p>
-        </p:txBody>
-      </p:sp>
-      <p:sp>
-        <p:nvSpPr>
-          <p:cNvPr id="27" name="文本框 26">
-            <a:extLst>
-              <a:ext uri="{FF2B5EF4-FFF2-40B4-BE49-F238E27FC236}">
-                <a16:creationId xmlns:a16="http://schemas.microsoft.com/office/drawing/2014/main" id="{B5839405-3880-173D-D156-B9BE64CA1EA2}"/>
-              </a:ext>
-            </a:extLst>
-          </p:cNvPr>
-          <p:cNvSpPr txBox="1"/>
-          <p:nvPr/>
-        </p:nvSpPr>
-        <p:spPr>
-          <a:xfrm>
-            <a:off x="3372985" y="1889770"/>
-            <a:ext cx="638316" cy="523220"/>
-          </a:xfrm>
-          <a:prstGeom prst="rect">
-            <a:avLst/>
-          </a:prstGeom>
-          <a:noFill/>
-        </p:spPr>
-        <p:txBody>
-          <a:bodyPr wrap="none" rtlCol="0">
-            <a:spAutoFit/>
-          </a:bodyPr>
-          <a:lstStyle/>
-          <a:p>
-            <a:r>
-              <a:rPr lang="zh-CN" altLang="en-US" sz="1400" dirty="0"/>
-              <a:t>学生</a:t>
-            </a:r>
-            <a:r>
-              <a:rPr lang="en-US" altLang="zh-CN" sz="1400" dirty="0"/>
-              <a:t>2</a:t>
-            </a:r>
-          </a:p>
-          <a:p>
-            <a:r>
-              <a:rPr lang="zh-CN" altLang="en-US" sz="1400" dirty="0"/>
-              <a:t>头像</a:t>
-            </a:r>
-          </a:p>
-        </p:txBody>
-      </p:sp>
-      <p:sp>
-        <p:nvSpPr>
-          <p:cNvPr id="29" name="文本框 28">
-            <a:extLst>
-              <a:ext uri="{FF2B5EF4-FFF2-40B4-BE49-F238E27FC236}">
-                <a16:creationId xmlns:a16="http://schemas.microsoft.com/office/drawing/2014/main" id="{0C71E826-68E3-AE99-2F3A-82A2F5DC4665}"/>
-              </a:ext>
-            </a:extLst>
-          </p:cNvPr>
-          <p:cNvSpPr txBox="1"/>
-          <p:nvPr/>
-        </p:nvSpPr>
-        <p:spPr>
-          <a:xfrm>
-            <a:off x="4881880" y="1212567"/>
-            <a:ext cx="1338828" cy="369332"/>
-          </a:xfrm>
-          <a:prstGeom prst="rect">
-            <a:avLst/>
-          </a:prstGeom>
-          <a:noFill/>
-        </p:spPr>
-        <p:txBody>
-          <a:bodyPr wrap="none" rtlCol="0">
-            <a:spAutoFit/>
-          </a:bodyPr>
-          <a:lstStyle/>
-          <a:p>
-            <a:r>
-              <a:rPr lang="zh-CN" altLang="en-US" dirty="0"/>
-              <a:t>课堂主界面</a:t>
-            </a:r>
-          </a:p>
-        </p:txBody>
-      </p:sp>
+        </p:grpSpPr>
+        <p:sp>
+          <p:nvSpPr>
+            <p:cNvPr id="4" name="矩形 3">
+              <a:extLst>
+                <a:ext uri="{FF2B5EF4-FFF2-40B4-BE49-F238E27FC236}">
+                  <a16:creationId xmlns:a16="http://schemas.microsoft.com/office/drawing/2014/main" id="{C65F594A-B440-FCDA-AA3B-5A7BAE929EF3}"/>
+                </a:ext>
+              </a:extLst>
+            </p:cNvPr>
+            <p:cNvSpPr/>
+            <p:nvPr/>
+          </p:nvSpPr>
+          <p:spPr>
+            <a:xfrm>
+              <a:off x="2402840" y="1788160"/>
+              <a:ext cx="6680200" cy="3581400"/>
+            </a:xfrm>
+            <a:prstGeom prst="rect">
+              <a:avLst/>
+            </a:prstGeom>
+          </p:spPr>
+          <p:style>
+            <a:lnRef idx="2">
+              <a:schemeClr val="dk1"/>
+            </a:lnRef>
+            <a:fillRef idx="1">
+              <a:schemeClr val="lt1"/>
+            </a:fillRef>
+            <a:effectRef idx="0">
+              <a:schemeClr val="dk1"/>
+            </a:effectRef>
+            <a:fontRef idx="minor">
+              <a:schemeClr val="dk1"/>
+            </a:fontRef>
+          </p:style>
+          <p:txBody>
+            <a:bodyPr rtlCol="0" anchor="ctr"/>
+            <a:lstStyle/>
+            <a:p>
+              <a:pPr algn="ctr"/>
+              <a:endParaRPr lang="zh-CN" altLang="en-US" dirty="0"/>
+            </a:p>
+          </p:txBody>
+        </p:sp>
+        <p:cxnSp>
+          <p:nvCxnSpPr>
+            <p:cNvPr id="6" name="直接连接符 5">
+              <a:extLst>
+                <a:ext uri="{FF2B5EF4-FFF2-40B4-BE49-F238E27FC236}">
+                  <a16:creationId xmlns:a16="http://schemas.microsoft.com/office/drawing/2014/main" id="{F0CC6497-AA8E-BD58-8AFC-B7891EEEC3F5}"/>
+                </a:ext>
+              </a:extLst>
+            </p:cNvPr>
+            <p:cNvCxnSpPr>
+              <a:cxnSpLocks/>
+            </p:cNvCxnSpPr>
+            <p:nvPr/>
+          </p:nvCxnSpPr>
+          <p:spPr>
+            <a:xfrm>
+              <a:off x="2448560" y="2438400"/>
+              <a:ext cx="6680200" cy="0"/>
+            </a:xfrm>
+            <a:prstGeom prst="line">
+              <a:avLst/>
+            </a:prstGeom>
+          </p:spPr>
+          <p:style>
+            <a:lnRef idx="2">
+              <a:schemeClr val="dk1"/>
+            </a:lnRef>
+            <a:fillRef idx="1">
+              <a:schemeClr val="lt1"/>
+            </a:fillRef>
+            <a:effectRef idx="0">
+              <a:schemeClr val="dk1"/>
+            </a:effectRef>
+            <a:fontRef idx="minor">
+              <a:schemeClr val="dk1"/>
+            </a:fontRef>
+          </p:style>
+        </p:cxnSp>
+        <p:cxnSp>
+          <p:nvCxnSpPr>
+            <p:cNvPr id="9" name="直接连接符 8">
+              <a:extLst>
+                <a:ext uri="{FF2B5EF4-FFF2-40B4-BE49-F238E27FC236}">
+                  <a16:creationId xmlns:a16="http://schemas.microsoft.com/office/drawing/2014/main" id="{6A3B0995-3EDB-CFD0-26AC-C5C6BAAA27D1}"/>
+                </a:ext>
+              </a:extLst>
+            </p:cNvPr>
+            <p:cNvCxnSpPr/>
+            <p:nvPr/>
+          </p:nvCxnSpPr>
+          <p:spPr>
+            <a:xfrm>
+              <a:off x="3271520" y="1793240"/>
+              <a:ext cx="0" cy="645160"/>
+            </a:xfrm>
+            <a:prstGeom prst="line">
+              <a:avLst/>
+            </a:prstGeom>
+          </p:spPr>
+          <p:style>
+            <a:lnRef idx="2">
+              <a:schemeClr val="dk1"/>
+            </a:lnRef>
+            <a:fillRef idx="1">
+              <a:schemeClr val="lt1"/>
+            </a:fillRef>
+            <a:effectRef idx="0">
+              <a:schemeClr val="dk1"/>
+            </a:effectRef>
+            <a:fontRef idx="minor">
+              <a:schemeClr val="dk1"/>
+            </a:fontRef>
+          </p:style>
+        </p:cxnSp>
+        <p:cxnSp>
+          <p:nvCxnSpPr>
+            <p:cNvPr id="11" name="直接连接符 10">
+              <a:extLst>
+                <a:ext uri="{FF2B5EF4-FFF2-40B4-BE49-F238E27FC236}">
+                  <a16:creationId xmlns:a16="http://schemas.microsoft.com/office/drawing/2014/main" id="{CD6853C0-46CF-71A7-AE31-726DB3A34A08}"/>
+                </a:ext>
+              </a:extLst>
+            </p:cNvPr>
+            <p:cNvCxnSpPr/>
+            <p:nvPr/>
+          </p:nvCxnSpPr>
+          <p:spPr>
+            <a:xfrm>
+              <a:off x="4094480" y="1788160"/>
+              <a:ext cx="0" cy="650240"/>
+            </a:xfrm>
+            <a:prstGeom prst="line">
+              <a:avLst/>
+            </a:prstGeom>
+          </p:spPr>
+          <p:style>
+            <a:lnRef idx="2">
+              <a:schemeClr val="dk1"/>
+            </a:lnRef>
+            <a:fillRef idx="1">
+              <a:schemeClr val="lt1"/>
+            </a:fillRef>
+            <a:effectRef idx="0">
+              <a:schemeClr val="dk1"/>
+            </a:effectRef>
+            <a:fontRef idx="minor">
+              <a:schemeClr val="dk1"/>
+            </a:fontRef>
+          </p:style>
+        </p:cxnSp>
+        <p:cxnSp>
+          <p:nvCxnSpPr>
+            <p:cNvPr id="13" name="直接连接符 12">
+              <a:extLst>
+                <a:ext uri="{FF2B5EF4-FFF2-40B4-BE49-F238E27FC236}">
+                  <a16:creationId xmlns:a16="http://schemas.microsoft.com/office/drawing/2014/main" id="{CA832CDB-2679-35D0-9DD2-593E1D9B4299}"/>
+                </a:ext>
+              </a:extLst>
+            </p:cNvPr>
+            <p:cNvCxnSpPr/>
+            <p:nvPr/>
+          </p:nvCxnSpPr>
+          <p:spPr>
+            <a:xfrm>
+              <a:off x="6659880" y="2438400"/>
+              <a:ext cx="0" cy="2931160"/>
+            </a:xfrm>
+            <a:prstGeom prst="line">
+              <a:avLst/>
+            </a:prstGeom>
+          </p:spPr>
+          <p:style>
+            <a:lnRef idx="2">
+              <a:schemeClr val="dk1"/>
+            </a:lnRef>
+            <a:fillRef idx="1">
+              <a:schemeClr val="lt1"/>
+            </a:fillRef>
+            <a:effectRef idx="0">
+              <a:schemeClr val="dk1"/>
+            </a:effectRef>
+            <a:fontRef idx="minor">
+              <a:schemeClr val="dk1"/>
+            </a:fontRef>
+          </p:style>
+        </p:cxnSp>
+        <p:cxnSp>
+          <p:nvCxnSpPr>
+            <p:cNvPr id="15" name="直接连接符 14">
+              <a:extLst>
+                <a:ext uri="{FF2B5EF4-FFF2-40B4-BE49-F238E27FC236}">
+                  <a16:creationId xmlns:a16="http://schemas.microsoft.com/office/drawing/2014/main" id="{D6E76A96-210E-7EDB-0BE4-03DC4A2338BB}"/>
+                </a:ext>
+              </a:extLst>
+            </p:cNvPr>
+            <p:cNvCxnSpPr/>
+            <p:nvPr/>
+          </p:nvCxnSpPr>
+          <p:spPr>
+            <a:xfrm>
+              <a:off x="6659880" y="3896360"/>
+              <a:ext cx="2423160" cy="0"/>
+            </a:xfrm>
+            <a:prstGeom prst="line">
+              <a:avLst/>
+            </a:prstGeom>
+          </p:spPr>
+          <p:style>
+            <a:lnRef idx="2">
+              <a:schemeClr val="dk1"/>
+            </a:lnRef>
+            <a:fillRef idx="1">
+              <a:schemeClr val="lt1"/>
+            </a:fillRef>
+            <a:effectRef idx="0">
+              <a:schemeClr val="dk1"/>
+            </a:effectRef>
+            <a:fontRef idx="minor">
+              <a:schemeClr val="dk1"/>
+            </a:fontRef>
+          </p:style>
+        </p:cxnSp>
+        <p:sp>
+          <p:nvSpPr>
+            <p:cNvPr id="18" name="文本框 17">
+              <a:extLst>
+                <a:ext uri="{FF2B5EF4-FFF2-40B4-BE49-F238E27FC236}">
+                  <a16:creationId xmlns:a16="http://schemas.microsoft.com/office/drawing/2014/main" id="{1CA803F5-C03C-E869-29D6-F1866DE73D54}"/>
+                </a:ext>
+              </a:extLst>
+            </p:cNvPr>
+            <p:cNvSpPr txBox="1"/>
+            <p:nvPr/>
+          </p:nvSpPr>
+          <p:spPr>
+            <a:xfrm>
+              <a:off x="6820882" y="2961640"/>
+              <a:ext cx="2262158" cy="646331"/>
+            </a:xfrm>
+            <a:prstGeom prst="rect">
+              <a:avLst/>
+            </a:prstGeom>
+            <a:noFill/>
+          </p:spPr>
+          <p:txBody>
+            <a:bodyPr wrap="none" rtlCol="0">
+              <a:spAutoFit/>
+            </a:bodyPr>
+            <a:lstStyle/>
+            <a:p>
+              <a:pPr algn="ctr"/>
+              <a:r>
+                <a:rPr lang="zh-CN" altLang="en-US" dirty="0"/>
+                <a:t>讲台区</a:t>
+              </a:r>
+              <a:endParaRPr lang="en-US" altLang="zh-CN" dirty="0"/>
+            </a:p>
+            <a:p>
+              <a:pPr algn="ctr"/>
+              <a:r>
+                <a:rPr lang="zh-CN" altLang="en-US" dirty="0"/>
+                <a:t>当前上台的学生头像</a:t>
+              </a:r>
+            </a:p>
+          </p:txBody>
+        </p:sp>
+        <p:sp>
+          <p:nvSpPr>
+            <p:cNvPr id="19" name="文本框 18">
+              <a:extLst>
+                <a:ext uri="{FF2B5EF4-FFF2-40B4-BE49-F238E27FC236}">
+                  <a16:creationId xmlns:a16="http://schemas.microsoft.com/office/drawing/2014/main" id="{E56D5EAE-D6B8-AFE5-BFB5-80C20A3266D1}"/>
+                </a:ext>
+              </a:extLst>
+            </p:cNvPr>
+            <p:cNvSpPr txBox="1"/>
+            <p:nvPr/>
+          </p:nvSpPr>
+          <p:spPr>
+            <a:xfrm>
+              <a:off x="7329884" y="4309795"/>
+              <a:ext cx="1107996" cy="646331"/>
+            </a:xfrm>
+            <a:prstGeom prst="rect">
+              <a:avLst/>
+            </a:prstGeom>
+            <a:noFill/>
+          </p:spPr>
+          <p:txBody>
+            <a:bodyPr wrap="none" rtlCol="0">
+              <a:spAutoFit/>
+            </a:bodyPr>
+            <a:lstStyle/>
+            <a:p>
+              <a:pPr algn="ctr"/>
+              <a:r>
+                <a:rPr lang="zh-CN" altLang="en-US" dirty="0"/>
+                <a:t>教师区</a:t>
+              </a:r>
+              <a:endParaRPr lang="en-US" altLang="zh-CN" dirty="0"/>
+            </a:p>
+            <a:p>
+              <a:pPr algn="ctr"/>
+              <a:r>
+                <a:rPr lang="zh-CN" altLang="en-US" dirty="0"/>
+                <a:t>教师头像</a:t>
+              </a:r>
+            </a:p>
+          </p:txBody>
+        </p:sp>
+        <p:sp>
+          <p:nvSpPr>
+            <p:cNvPr id="20" name="文本框 19">
+              <a:extLst>
+                <a:ext uri="{FF2B5EF4-FFF2-40B4-BE49-F238E27FC236}">
+                  <a16:creationId xmlns:a16="http://schemas.microsoft.com/office/drawing/2014/main" id="{8AD0230A-5180-1EEC-137B-B7434374EE34}"/>
+                </a:ext>
+              </a:extLst>
+            </p:cNvPr>
+            <p:cNvSpPr txBox="1"/>
+            <p:nvPr/>
+          </p:nvSpPr>
+          <p:spPr>
+            <a:xfrm>
+              <a:off x="3939308" y="3711694"/>
+              <a:ext cx="877163" cy="646331"/>
+            </a:xfrm>
+            <a:prstGeom prst="rect">
+              <a:avLst/>
+            </a:prstGeom>
+            <a:noFill/>
+          </p:spPr>
+          <p:txBody>
+            <a:bodyPr wrap="none" rtlCol="0">
+              <a:spAutoFit/>
+            </a:bodyPr>
+            <a:lstStyle/>
+            <a:p>
+              <a:r>
+                <a:rPr lang="zh-CN" altLang="en-US" dirty="0"/>
+                <a:t>课件区</a:t>
+              </a:r>
+              <a:endParaRPr lang="en-US" altLang="zh-CN" dirty="0"/>
+            </a:p>
+            <a:p>
+              <a:pPr algn="ctr"/>
+              <a:r>
+                <a:rPr lang="zh-CN" altLang="en-US" dirty="0"/>
+                <a:t>图片</a:t>
+              </a:r>
+            </a:p>
+          </p:txBody>
+        </p:sp>
+        <p:cxnSp>
+          <p:nvCxnSpPr>
+            <p:cNvPr id="21" name="直接连接符 20">
+              <a:extLst>
+                <a:ext uri="{FF2B5EF4-FFF2-40B4-BE49-F238E27FC236}">
+                  <a16:creationId xmlns:a16="http://schemas.microsoft.com/office/drawing/2014/main" id="{6F854512-E40A-E0B8-772E-2EF2C11D6E4B}"/>
+                </a:ext>
+              </a:extLst>
+            </p:cNvPr>
+            <p:cNvCxnSpPr/>
+            <p:nvPr/>
+          </p:nvCxnSpPr>
+          <p:spPr>
+            <a:xfrm>
+              <a:off x="4881880" y="1793240"/>
+              <a:ext cx="0" cy="645160"/>
+            </a:xfrm>
+            <a:prstGeom prst="line">
+              <a:avLst/>
+            </a:prstGeom>
+          </p:spPr>
+          <p:style>
+            <a:lnRef idx="2">
+              <a:schemeClr val="dk1"/>
+            </a:lnRef>
+            <a:fillRef idx="1">
+              <a:schemeClr val="lt1"/>
+            </a:fillRef>
+            <a:effectRef idx="0">
+              <a:schemeClr val="dk1"/>
+            </a:effectRef>
+            <a:fontRef idx="minor">
+              <a:schemeClr val="dk1"/>
+            </a:fontRef>
+          </p:style>
+        </p:cxnSp>
+        <p:cxnSp>
+          <p:nvCxnSpPr>
+            <p:cNvPr id="22" name="直接连接符 21">
+              <a:extLst>
+                <a:ext uri="{FF2B5EF4-FFF2-40B4-BE49-F238E27FC236}">
+                  <a16:creationId xmlns:a16="http://schemas.microsoft.com/office/drawing/2014/main" id="{B78D0309-DCF7-1C9F-6B34-C1F31BAF5F92}"/>
+                </a:ext>
+              </a:extLst>
+            </p:cNvPr>
+            <p:cNvCxnSpPr/>
+            <p:nvPr/>
+          </p:nvCxnSpPr>
+          <p:spPr>
+            <a:xfrm>
+              <a:off x="5633720" y="1788160"/>
+              <a:ext cx="0" cy="645160"/>
+            </a:xfrm>
+            <a:prstGeom prst="line">
+              <a:avLst/>
+            </a:prstGeom>
+          </p:spPr>
+          <p:style>
+            <a:lnRef idx="2">
+              <a:schemeClr val="dk1"/>
+            </a:lnRef>
+            <a:fillRef idx="1">
+              <a:schemeClr val="lt1"/>
+            </a:fillRef>
+            <a:effectRef idx="0">
+              <a:schemeClr val="dk1"/>
+            </a:effectRef>
+            <a:fontRef idx="minor">
+              <a:schemeClr val="dk1"/>
+            </a:fontRef>
+          </p:style>
+        </p:cxnSp>
+        <p:cxnSp>
+          <p:nvCxnSpPr>
+            <p:cNvPr id="23" name="直接连接符 22">
+              <a:extLst>
+                <a:ext uri="{FF2B5EF4-FFF2-40B4-BE49-F238E27FC236}">
+                  <a16:creationId xmlns:a16="http://schemas.microsoft.com/office/drawing/2014/main" id="{7996573E-2F88-136E-7BAA-AE744BAE7FE0}"/>
+                </a:ext>
+              </a:extLst>
+            </p:cNvPr>
+            <p:cNvCxnSpPr/>
+            <p:nvPr/>
+          </p:nvCxnSpPr>
+          <p:spPr>
+            <a:xfrm>
+              <a:off x="6421120" y="1795780"/>
+              <a:ext cx="0" cy="645160"/>
+            </a:xfrm>
+            <a:prstGeom prst="line">
+              <a:avLst/>
+            </a:prstGeom>
+          </p:spPr>
+          <p:style>
+            <a:lnRef idx="2">
+              <a:schemeClr val="dk1"/>
+            </a:lnRef>
+            <a:fillRef idx="1">
+              <a:schemeClr val="lt1"/>
+            </a:fillRef>
+            <a:effectRef idx="0">
+              <a:schemeClr val="dk1"/>
+            </a:effectRef>
+            <a:fontRef idx="minor">
+              <a:schemeClr val="dk1"/>
+            </a:fontRef>
+          </p:style>
+        </p:cxnSp>
+        <p:cxnSp>
+          <p:nvCxnSpPr>
+            <p:cNvPr id="24" name="直接连接符 23">
+              <a:extLst>
+                <a:ext uri="{FF2B5EF4-FFF2-40B4-BE49-F238E27FC236}">
+                  <a16:creationId xmlns:a16="http://schemas.microsoft.com/office/drawing/2014/main" id="{B22994B3-61DE-C9E1-9F1D-0537084832B2}"/>
+                </a:ext>
+              </a:extLst>
+            </p:cNvPr>
+            <p:cNvCxnSpPr/>
+            <p:nvPr/>
+          </p:nvCxnSpPr>
+          <p:spPr>
+            <a:xfrm>
+              <a:off x="7374880" y="1788160"/>
+              <a:ext cx="0" cy="645160"/>
+            </a:xfrm>
+            <a:prstGeom prst="line">
+              <a:avLst/>
+            </a:prstGeom>
+          </p:spPr>
+          <p:style>
+            <a:lnRef idx="2">
+              <a:schemeClr val="dk1"/>
+            </a:lnRef>
+            <a:fillRef idx="1">
+              <a:schemeClr val="lt1"/>
+            </a:fillRef>
+            <a:effectRef idx="0">
+              <a:schemeClr val="dk1"/>
+            </a:effectRef>
+            <a:fontRef idx="minor">
+              <a:schemeClr val="dk1"/>
+            </a:fontRef>
+          </p:style>
+        </p:cxnSp>
+        <p:cxnSp>
+          <p:nvCxnSpPr>
+            <p:cNvPr id="25" name="直接连接符 24">
+              <a:extLst>
+                <a:ext uri="{FF2B5EF4-FFF2-40B4-BE49-F238E27FC236}">
+                  <a16:creationId xmlns:a16="http://schemas.microsoft.com/office/drawing/2014/main" id="{65B06274-DF29-4A65-E54A-86B1CE4758AD}"/>
+                </a:ext>
+              </a:extLst>
+            </p:cNvPr>
+            <p:cNvCxnSpPr/>
+            <p:nvPr/>
+          </p:nvCxnSpPr>
+          <p:spPr>
+            <a:xfrm>
+              <a:off x="8177520" y="1828800"/>
+              <a:ext cx="0" cy="645160"/>
+            </a:xfrm>
+            <a:prstGeom prst="line">
+              <a:avLst/>
+            </a:prstGeom>
+          </p:spPr>
+          <p:style>
+            <a:lnRef idx="2">
+              <a:schemeClr val="dk1"/>
+            </a:lnRef>
+            <a:fillRef idx="1">
+              <a:schemeClr val="lt1"/>
+            </a:fillRef>
+            <a:effectRef idx="0">
+              <a:schemeClr val="dk1"/>
+            </a:effectRef>
+            <a:fontRef idx="minor">
+              <a:schemeClr val="dk1"/>
+            </a:fontRef>
+          </p:style>
+        </p:cxnSp>
+        <p:sp>
+          <p:nvSpPr>
+            <p:cNvPr id="26" name="文本框 25">
+              <a:extLst>
+                <a:ext uri="{FF2B5EF4-FFF2-40B4-BE49-F238E27FC236}">
+                  <a16:creationId xmlns:a16="http://schemas.microsoft.com/office/drawing/2014/main" id="{BB3A0EDF-924E-5208-BCC3-D58961197EFC}"/>
+                </a:ext>
+              </a:extLst>
+            </p:cNvPr>
+            <p:cNvSpPr txBox="1"/>
+            <p:nvPr/>
+          </p:nvSpPr>
+          <p:spPr>
+            <a:xfrm>
+              <a:off x="2553583" y="1871990"/>
+              <a:ext cx="638316" cy="523220"/>
+            </a:xfrm>
+            <a:prstGeom prst="rect">
+              <a:avLst/>
+            </a:prstGeom>
+            <a:noFill/>
+          </p:spPr>
+          <p:txBody>
+            <a:bodyPr wrap="none" rtlCol="0">
+              <a:spAutoFit/>
+            </a:bodyPr>
+            <a:lstStyle/>
+            <a:p>
+              <a:r>
+                <a:rPr lang="zh-CN" altLang="en-US" sz="1400" dirty="0"/>
+                <a:t>学生</a:t>
+              </a:r>
+              <a:r>
+                <a:rPr lang="en-US" altLang="zh-CN" sz="1400" dirty="0"/>
+                <a:t>1</a:t>
+              </a:r>
+            </a:p>
+            <a:p>
+              <a:r>
+                <a:rPr lang="zh-CN" altLang="en-US" sz="1400" dirty="0"/>
+                <a:t>头像</a:t>
+              </a:r>
+            </a:p>
+          </p:txBody>
+        </p:sp>
+        <p:sp>
+          <p:nvSpPr>
+            <p:cNvPr id="27" name="文本框 26">
+              <a:extLst>
+                <a:ext uri="{FF2B5EF4-FFF2-40B4-BE49-F238E27FC236}">
+                  <a16:creationId xmlns:a16="http://schemas.microsoft.com/office/drawing/2014/main" id="{B5839405-3880-173D-D156-B9BE64CA1EA2}"/>
+                </a:ext>
+              </a:extLst>
+            </p:cNvPr>
+            <p:cNvSpPr txBox="1"/>
+            <p:nvPr/>
+          </p:nvSpPr>
+          <p:spPr>
+            <a:xfrm>
+              <a:off x="3372985" y="1889770"/>
+              <a:ext cx="638316" cy="523220"/>
+            </a:xfrm>
+            <a:prstGeom prst="rect">
+              <a:avLst/>
+            </a:prstGeom>
+            <a:noFill/>
+          </p:spPr>
+          <p:txBody>
+            <a:bodyPr wrap="none" rtlCol="0">
+              <a:spAutoFit/>
+            </a:bodyPr>
+            <a:lstStyle/>
+            <a:p>
+              <a:r>
+                <a:rPr lang="zh-CN" altLang="en-US" sz="1400" dirty="0"/>
+                <a:t>学生</a:t>
+              </a:r>
+              <a:r>
+                <a:rPr lang="en-US" altLang="zh-CN" sz="1400" dirty="0"/>
+                <a:t>2</a:t>
+              </a:r>
+            </a:p>
+            <a:p>
+              <a:r>
+                <a:rPr lang="zh-CN" altLang="en-US" sz="1400" dirty="0"/>
+                <a:t>头像</a:t>
+              </a:r>
+            </a:p>
+          </p:txBody>
+        </p:sp>
+        <p:sp>
+          <p:nvSpPr>
+            <p:cNvPr id="29" name="文本框 28">
+              <a:extLst>
+                <a:ext uri="{FF2B5EF4-FFF2-40B4-BE49-F238E27FC236}">
+                  <a16:creationId xmlns:a16="http://schemas.microsoft.com/office/drawing/2014/main" id="{0C71E826-68E3-AE99-2F3A-82A2F5DC4665}"/>
+                </a:ext>
+              </a:extLst>
+            </p:cNvPr>
+            <p:cNvSpPr txBox="1"/>
+            <p:nvPr/>
+          </p:nvSpPr>
+          <p:spPr>
+            <a:xfrm>
+              <a:off x="4881880" y="1212567"/>
+              <a:ext cx="1338828" cy="369332"/>
+            </a:xfrm>
+            <a:prstGeom prst="rect">
+              <a:avLst/>
+            </a:prstGeom>
+            <a:noFill/>
+          </p:spPr>
+          <p:txBody>
+            <a:bodyPr wrap="none" rtlCol="0">
+              <a:spAutoFit/>
+            </a:bodyPr>
+            <a:lstStyle/>
+            <a:p>
+              <a:r>
+                <a:rPr lang="zh-CN" altLang="en-US" dirty="0"/>
+                <a:t>课堂主界面</a:t>
+              </a:r>
+            </a:p>
+          </p:txBody>
+        </p:sp>
+      </p:grpSp>
     </p:spTree>
     <p:extLst>
       <p:ext uri="{BB962C8B-B14F-4D97-AF65-F5344CB8AC3E}">

</xml_diff>